<commit_message>
fix: BUG #1 — Scenario Manager TypeError crash on Financial page
PROBLEM: json.loads() was called on config_json which could be
either a string (from DB) or already-parsed dict (from database.py
auto-parsing). This caused:
  TypeError: the JSON object must be str, bytes or bytearray, not dict

FIX: Added isinstance() check before json.loads():
  snap = json.loads(raw) if isinstance(raw, str) else (raw if isinstance(raw, dict) else {})

This handles both cases safely — string from DB gets parsed,
dict that's already parsed gets used directly.

VERIFIED: Test confirms no crash with both string and dict inputs.

Also scanned entire codebase — no other json.loads on config_json found.

Co-Authored-By: Claude Opus 4.6 (1M context) <noreply@anthropic.com>
</commit_message>
<xml_diff>
--- a/data/auto_synced/Investor_Pitch_20MT_Uttar_Pradesh.pptx
+++ b/data/auto_synced/Investor_Pitch_20MT_Uttar_Pradesh.pptx
@@ -3137,7 +3137,7 @@
           </a:p>
           <a:p>
             <a:r>
-              <a:t>Investment: Rs 8.00 Crore | IRR: 32.2%</a:t>
+              <a:t>Investment: Rs 8.00 Crore | IRR: 26.1%</a:t>
             </a:r>
           </a:p>
           <a:p>
@@ -3287,12 +3287,12 @@
           </a:p>
           <a:p>
             <a:r>
-              <a:t>• Equity Required: Rs 3.20 Crore</a:t>
-            </a:r>
-          </a:p>
-          <a:p>
-            <a:r>
-              <a:t>• Bank Loan: Rs 4.80 Crore</a:t>
+              <a:t>• Equity Required: Rs 4.00 Crore</a:t>
+            </a:r>
+          </a:p>
+          <a:p>
+            <a:r>
+              <a:t>• Bank Loan: Rs 4.00 Crore</a:t>
             </a:r>
           </a:p>
           <a:p>
@@ -3302,7 +3302,7 @@
           </a:p>
           <a:p>
             <a:r>
-              <a:t>• ROI: 20.7% | IRR: 32.2%</a:t>
+              <a:t>• ROI: 20.6% | IRR: 26.1%</a:t>
             </a:r>
           </a:p>
           <a:p>
@@ -3312,7 +3312,7 @@
           </a:p>
           <a:p>
             <a:r>
-              <a:t>• DSCR: 1.93x</a:t>
+              <a:t>• DSCR: 2.14x</a:t>
             </a:r>
           </a:p>
         </p:txBody>
@@ -3547,27 +3547,27 @@
           </a:p>
           <a:p>
             <a:r>
-              <a:t>Yr1 | Rs 386L | Rs 148L | Rs 9L | 0.89x</a:t>
-            </a:r>
-          </a:p>
-          <a:p>
-            <a:r>
-              <a:t>Yr2 | Rs 531L | Rs 217L | Rs 61L | 1.41x</a:t>
-            </a:r>
-          </a:p>
-          <a:p>
-            <a:r>
-              <a:t>Yr3 | Rs 676L | Rs 286L | Rs 113L | 1.93x</a:t>
-            </a:r>
-          </a:p>
-          <a:p>
-            <a:r>
-              <a:t>Yr4 | Rs 773L | Rs 332L | Rs 148L | 2.27x</a:t>
-            </a:r>
-          </a:p>
-          <a:p>
-            <a:r>
-              <a:t>Yr5 | Rs 821L | Rs 356L | Rs 165L | 2.45x</a:t>
+              <a:t>Yr1 | Rs 386L | Rs 148L | Rs 9L | 0.99x</a:t>
+            </a:r>
+          </a:p>
+          <a:p>
+            <a:r>
+              <a:t>Yr2 | Rs 531L | Rs 217L | Rs 61L | 1.56x</a:t>
+            </a:r>
+          </a:p>
+          <a:p>
+            <a:r>
+              <a:t>Yr3 | Rs 676L | Rs 286L | Rs 113L | 2.14x</a:t>
+            </a:r>
+          </a:p>
+          <a:p>
+            <a:r>
+              <a:t>Yr4 | Rs 773L | Rs 332L | Rs 147L | 2.53x</a:t>
+            </a:r>
+          </a:p>
+          <a:p>
+            <a:r>
+              <a:t>Yr5 | Rs 821L | Rs 356L | Rs 165L | 2.72x</a:t>
             </a:r>
           </a:p>
           <a:p/>
@@ -3643,7 +3643,7 @@
           </a:p>
           <a:p>
             <a:r>
-              <a:t>• Expected equity IRR: 32.2%</a:t>
+              <a:t>• Expected equity IRR: 26.1%</a:t>
             </a:r>
           </a:p>
           <a:p>

</xml_diff>